<commit_message>
docs: troca 'peca(s)' por 'quantidade(s)' no slide 7 da apresentacao
</commit_message>
<xml_diff>
--- a/docs/Apresentacao_Apontamentos_Lideres_2026-07.pptx
+++ b/docs/Apresentacao_Apontamentos_Lideres_2026-07.pptx
@@ -4696,7 +4696,7 @@
                 <a:ea typeface="Calibri" pitchFamily="34" charset="-122"/>
                 <a:cs typeface="Calibri" pitchFamily="34" charset="-120"/>
               </a:rPr>
-              <a:t>Nenhuma etapa é pulada sem justificativa registrada. Se a peça precisa de retrabalho, ela passa pelo retrabalho.</a:t>
+              <a:t>Nenhuma etapa é pulada sem justificativa registrada. Se a quantidade precisa de retrabalho, ela passa pelo retrabalho.</a:t>
             </a:r>
             <a:endParaRPr lang="en-US" sz="1350" dirty="0"/>
           </a:p>
@@ -4821,7 +4821,7 @@
                 <a:ea typeface="Calibri" pitchFamily="34" charset="-122"/>
                 <a:cs typeface="Calibri" pitchFamily="34" charset="-120"/>
               </a:rPr>
-              <a:t>Peças de apontamentos/setores diferentes não são embaladas ou misturadas juntas.</a:t>
+              <a:t>Quantidades de apontamentos/setores diferentes não são embaladas ou misturadas juntas.</a:t>
             </a:r>
             <a:endParaRPr lang="en-US" sz="1350" dirty="0"/>
           </a:p>
@@ -4946,7 +4946,7 @@
                 <a:ea typeface="Calibri" pitchFamily="34" charset="-122"/>
                 <a:cs typeface="Calibri" pitchFamily="34" charset="-120"/>
               </a:rPr>
-              <a:t>Etapa pulada, peça misturada, apontamento esquecido: avisar o PCP antes de continuar. Corrigir depois é bem mais difícil.</a:t>
+              <a:t>Etapa pulada, quantidade misturada, apontamento esquecido: avisar o PCP antes de continuar. Corrigir depois é bem mais difícil.</a:t>
             </a:r>
             <a:endParaRPr lang="en-US" sz="1350" dirty="0"/>
           </a:p>

</xml_diff>

<commit_message>
docs: adiciona slide sobre comunicacao na apresentacao para lideres
Novo slide 7: reforca que toda finalizacao/encaminhamento de peca,
quantidade ou pedido precisa ser comunicado no sistema nesta fase inicial
de adocao, e registra que esta em avaliacao retirar os pedidos de corte
manual do fluxo informal ("no olho").
</commit_message>
<xml_diff>
--- a/docs/Apresentacao_Apontamentos_Lideres_2026-07.pptx
+++ b/docs/Apresentacao_Apontamentos_Lideres_2026-07.pptx
@@ -13,9 +13,10 @@
     <p:sldId id="261" r:id="rId7"/>
     <p:sldId id="262" r:id="rId8"/>
     <p:sldId id="263" r:id="rId9"/>
+    <p:sldId id="264" r:id="rId10"/>
   </p:sldIdLst>
   <p:notesMasterIdLst>
-    <p:notesMasterId r:id="rId10"/>
+    <p:notesMasterId r:id="rId11"/>
   </p:notesMasterIdLst>
   <p:sldSz cx="12192000" cy="6858000"/>
   <p:notesSz cx="6858000" cy="12192000"/>
@@ -1149,6 +1150,94 @@
             <a:fld id="{F7021451-1387-4CA6-816F-3879F97B5CBC}" type="slidenum">
               <a:rPr lang="en-US"/>
               <a:t>8</a:t>
+            </a:fld>
+            <a:endParaRPr lang="en-US"/>
+          </a:p>
+        </p:txBody>
+      </p:sp>
+    </p:spTree>
+    <p:extLst>
+      <p:ext uri="{BB962C8B-B14F-4D97-AF65-F5344CB8AC3E}">
+        <p14:creationId xmlns:p14="http://schemas.microsoft.com/office/powerpoint/2010/main" val="1024086991"/>
+      </p:ext>
+    </p:extLst>
+  </p:cSld>
+  <p:clrMapOvr>
+    <a:masterClrMapping/>
+  </p:clrMapOvr>
+</p:notes>
+</file>
+
+<file path=ppt/notesSlides/notesSlide9.xml><?xml version="1.0" encoding="utf-8"?>
+<p:notes xmlns:a="http://schemas.openxmlformats.org/drawingml/2006/main" xmlns:r="http://schemas.openxmlformats.org/officeDocument/2006/relationships" xmlns:p="http://schemas.openxmlformats.org/presentationml/2006/main">
+  <p:cSld>
+    <p:spTree>
+      <p:nvGrpSpPr>
+        <p:cNvPr id="1" name=""/>
+        <p:cNvGrpSpPr/>
+        <p:nvPr/>
+      </p:nvGrpSpPr>
+      <p:grpSpPr>
+        <a:xfrm>
+          <a:off x="0" y="0"/>
+          <a:ext cx="0" cy="0"/>
+          <a:chOff x="0" y="0"/>
+          <a:chExt cx="0" cy="0"/>
+        </a:xfrm>
+      </p:grpSpPr>
+      <p:sp>
+        <p:nvSpPr>
+          <p:cNvPr id="2" name="Slide Image Placeholder 1"/>
+          <p:cNvSpPr>
+            <a:spLocks noGrp="1" noRot="1" noChangeAspect="1"/>
+          </p:cNvSpPr>
+          <p:nvPr>
+            <p:ph type="sldImg"/>
+          </p:nvPr>
+        </p:nvSpPr>
+        <p:spPr/>
+      </p:sp>
+      <p:sp>
+        <p:nvSpPr>
+          <p:cNvPr id="3" name="Notes Placeholder 2"/>
+          <p:cNvSpPr>
+            <a:spLocks noGrp="1"/>
+          </p:cNvSpPr>
+          <p:nvPr>
+            <p:ph type="body" idx="1"/>
+          </p:nvPr>
+        </p:nvSpPr>
+        <p:spPr/>
+        <p:txBody>
+          <a:bodyPr/>
+          <a:lstStyle/>
+          <a:p>
+            <a:r>
+              <a:rPr lang="en-US" dirty="0"/>
+              <a:t/>
+            </a:r>
+            <a:endParaRPr lang="en-US" dirty="0"/>
+          </a:p>
+        </p:txBody>
+      </p:sp>
+      <p:sp>
+        <p:nvSpPr>
+          <p:cNvPr id="4" name="Slide Number Placeholder 3"/>
+          <p:cNvSpPr>
+            <a:spLocks noGrp="1"/>
+          </p:cNvSpPr>
+          <p:nvPr>
+            <p:ph type="sldNum" sz="quarter" idx="10"/>
+          </p:nvPr>
+        </p:nvSpPr>
+        <p:spPr/>
+        <p:txBody>
+          <a:bodyPr/>
+          <a:lstStyle/>
+          <a:p>
+            <a:fld id="{F7021451-1387-4CA6-816F-3879F97B5CBC}" type="slidenum">
+              <a:rPr lang="en-US"/>
+              <a:t>9</a:t>
             </a:fld>
             <a:endParaRPr lang="en-US"/>
           </a:p>
@@ -1762,7 +1851,7 @@
         <p:spPr>
           <a:xfrm>
             <a:off x="640080" y="502920"/>
-            <a:ext cx="7315200" cy="320040"/>
+            <a:ext cx="8229600" cy="320040"/>
           </a:xfrm>
           <a:prstGeom prst="rect">
             <a:avLst/>
@@ -2187,7 +2276,7 @@
         <p:spPr>
           <a:xfrm>
             <a:off x="640080" y="502920"/>
-            <a:ext cx="7315200" cy="320040"/>
+            <a:ext cx="8229600" cy="320040"/>
           </a:xfrm>
           <a:prstGeom prst="rect">
             <a:avLst/>
@@ -2808,7 +2897,7 @@
         <p:spPr>
           <a:xfrm>
             <a:off x="640080" y="502920"/>
-            <a:ext cx="7315200" cy="320040"/>
+            <a:ext cx="8229600" cy="320040"/>
           </a:xfrm>
           <a:prstGeom prst="rect">
             <a:avLst/>
@@ -3335,7 +3424,7 @@
         <p:spPr>
           <a:xfrm>
             <a:off x="640080" y="502920"/>
-            <a:ext cx="7315200" cy="320040"/>
+            <a:ext cx="8229600" cy="320040"/>
           </a:xfrm>
           <a:prstGeom prst="rect">
             <a:avLst/>
@@ -4383,7 +4472,7 @@
         <p:spPr>
           <a:xfrm>
             <a:off x="640080" y="502920"/>
-            <a:ext cx="7315200" cy="320040"/>
+            <a:ext cx="8229600" cy="320040"/>
           </a:xfrm>
           <a:prstGeom prst="rect">
             <a:avLst/>
@@ -4407,7 +4496,7 @@
                 <a:ea typeface="Calibri" pitchFamily="34" charset="-122"/>
                 <a:cs typeface="Calibri" pitchFamily="34" charset="-120"/>
               </a:rPr>
-              <a:t>A PARTIR DE AGORA</a:t>
+              <a:t>COMUNICAÇÃO NESTA FASE INICIAL</a:t>
             </a:r>
             <a:endParaRPr lang="en-US" sz="1200" dirty="0"/>
           </a:p>
@@ -4422,7 +4511,7 @@
         <p:spPr>
           <a:xfrm>
             <a:off x="640080" y="868680"/>
-            <a:ext cx="10881360" cy="822960"/>
+            <a:ext cx="10881360" cy="1051560"/>
           </a:xfrm>
           <a:prstGeom prst="rect">
             <a:avLst/>
@@ -4435,6 +4524,9 @@
           <a:lstStyle/>
           <a:p>
             <a:pPr indent="0" marL="0">
+              <a:lnSpc>
+                <a:spcPct val="105000"/>
+              </a:lnSpc>
               <a:buNone/>
             </a:pPr>
             <a:r>
@@ -4446,10 +4538,30 @@
                 <a:ea typeface="Cambria" pitchFamily="34" charset="-122"/>
                 <a:cs typeface="Cambria" pitchFamily="34" charset="-120"/>
               </a:rPr>
-              <a:t>O que cada líder precisa garantir na sua equipe</a:t>
+              <a:t>Toda finalização e todo encaminhamento</a:t>
             </a:r>
             <a:endParaRPr lang="en-US" sz="2800" dirty="0"/>
           </a:p>
+          <a:p>
+            <a:pPr indent="0" marL="0">
+              <a:lnSpc>
+                <a:spcPct val="105000"/>
+              </a:lnSpc>
+              <a:buNone/>
+            </a:pPr>
+            <a:r>
+              <a:rPr lang="en-US" sz="2800" b="1" dirty="0">
+                <a:solidFill>
+                  <a:srgbClr val="1A3A5C"/>
+                </a:solidFill>
+                <a:latin typeface="Cambria" pitchFamily="34" charset="0"/>
+                <a:ea typeface="Cambria" pitchFamily="34" charset="-122"/>
+                <a:cs typeface="Cambria" pitchFamily="34" charset="-120"/>
+              </a:rPr>
+              <a:t>precisam ser comunicados</a:t>
+            </a:r>
+            <a:endParaRPr lang="en-US" sz="2800" dirty="0"/>
+          </a:p>
         </p:txBody>
       </p:sp>
       <p:sp>
@@ -4460,7 +4572,7 @@
         </p:nvSpPr>
         <p:spPr>
           <a:xfrm>
-            <a:off x="640080" y="2130552"/>
+            <a:off x="640080" y="2331720"/>
             <a:ext cx="566928" cy="566928"/>
           </a:xfrm>
           <a:prstGeom prst="ellipse">
@@ -4474,7 +4586,7 @@
       </p:sp>
       <p:pic>
         <p:nvPicPr>
-          <p:cNvPr id="5" name="Image 0" descr="C:\Users\GUILHE~1.SAN\AppData\Local\Temp\claude\C--Users-guilherme-santos-Desktop-sistema-pcp\4d21c026-892e-446d-879f-b79089ffc749\scratchpad/icons/clipboard.png">    </p:cNvPr>
+          <p:cNvPr id="5" name="Image 0" descr="C:\Users\GUILHE~1.SAN\AppData\Local\Temp\claude\C--Users-guilherme-santos-Desktop-sistema-pcp\4d21c026-892e-446d-879f-b79089ffc749\scratchpad/icons/message.png">    </p:cNvPr>
           <p:cNvPicPr>
             <a:picLocks noChangeAspect="1"/>
           </p:cNvPicPr>
@@ -4488,7 +4600,7 @@
         </p:blipFill>
         <p:spPr>
           <a:xfrm>
-            <a:off x="702442" y="2192914"/>
+            <a:off x="702442" y="2394082"/>
             <a:ext cx="442204" cy="442204"/>
           </a:xfrm>
           <a:prstGeom prst="rect">
@@ -4504,34 +4616,37 @@
         </p:nvSpPr>
         <p:spPr>
           <a:xfrm>
-            <a:off x="1463040" y="1965960"/>
-            <a:ext cx="9509760" cy="365760"/>
-          </a:xfrm>
-          <a:prstGeom prst="rect">
-            <a:avLst/>
-          </a:prstGeom>
-          <a:noFill/>
-          <a:ln/>
-        </p:spPr>
-        <p:txBody>
-          <a:bodyPr wrap="square" rtlCol="0" anchor="ctr"/>
+            <a:off x="1463040" y="2286000"/>
+            <a:ext cx="9509760" cy="1051560"/>
+          </a:xfrm>
+          <a:prstGeom prst="rect">
+            <a:avLst/>
+          </a:prstGeom>
+          <a:noFill/>
+          <a:ln/>
+        </p:spPr>
+        <p:txBody>
+          <a:bodyPr wrap="square" rtlCol="0" anchor="t"/>
           <a:lstStyle/>
           <a:p>
             <a:pPr indent="0" marL="0">
-              <a:buNone/>
-            </a:pPr>
-            <a:r>
-              <a:rPr lang="en-US" sz="1600" b="1" dirty="0">
-                <a:solidFill>
-                  <a:srgbClr val="1A3A5C"/>
+              <a:lnSpc>
+                <a:spcPct val="125000"/>
+              </a:lnSpc>
+              <a:buNone/>
+            </a:pPr>
+            <a:r>
+              <a:rPr lang="en-US" sz="1500" dirty="0">
+                <a:solidFill>
+                  <a:srgbClr val="1F2937"/>
                 </a:solidFill>
                 <a:latin typeface="Calibri" pitchFamily="34" charset="0"/>
                 <a:ea typeface="Calibri" pitchFamily="34" charset="-122"/>
                 <a:cs typeface="Calibri" pitchFamily="34" charset="-120"/>
               </a:rPr>
-              <a:t>Apontar sempre, na hora</a:t>
-            </a:r>
-            <a:endParaRPr lang="en-US" sz="1600" dirty="0"/>
+              <a:t>Sempre que uma peça, uma quantidade ou um pedido inteiro for finalizado e encaminhado para a próxima etapa, isso precisa ser comunicado — apontado no sistema, e avisado a quem vai receber.</a:t>
+            </a:r>
+            <a:endParaRPr lang="en-US" sz="1500" dirty="0"/>
           </a:p>
         </p:txBody>
       </p:sp>
@@ -4543,37 +4658,37 @@
         </p:nvSpPr>
         <p:spPr>
           <a:xfrm>
-            <a:off x="1463040" y="2350008"/>
-            <a:ext cx="9509760" cy="594360"/>
-          </a:xfrm>
-          <a:prstGeom prst="rect">
-            <a:avLst/>
-          </a:prstGeom>
-          <a:noFill/>
-          <a:ln/>
-        </p:spPr>
-        <p:txBody>
-          <a:bodyPr wrap="square" rtlCol="0" anchor="ctr"/>
+            <a:off x="1463040" y="3310128"/>
+            <a:ext cx="9509760" cy="548640"/>
+          </a:xfrm>
+          <a:prstGeom prst="rect">
+            <a:avLst/>
+          </a:prstGeom>
+          <a:noFill/>
+          <a:ln/>
+        </p:spPr>
+        <p:txBody>
+          <a:bodyPr wrap="square" rtlCol="0" anchor="t"/>
           <a:lstStyle/>
           <a:p>
             <a:pPr indent="0" marL="0">
               <a:lnSpc>
-                <a:spcPct val="115000"/>
+                <a:spcPct val="120000"/>
               </a:lnSpc>
               <a:buNone/>
             </a:pPr>
             <a:r>
-              <a:rPr lang="en-US" sz="1350" dirty="0">
-                <a:solidFill>
-                  <a:srgbClr val="1F2937"/>
+              <a:rPr lang="en-US" sz="1400" i="1" dirty="0">
+                <a:solidFill>
+                  <a:srgbClr val="5A6A80"/>
                 </a:solidFill>
                 <a:latin typeface="Calibri" pitchFamily="34" charset="0"/>
                 <a:ea typeface="Calibri" pitchFamily="34" charset="-122"/>
                 <a:cs typeface="Calibri" pitchFamily="34" charset="-120"/>
               </a:rPr>
-              <a:t>Cada movimento é registrado no sistema no momento em que acontece — não depois, não "quando der tempo".</a:t>
-            </a:r>
-            <a:endParaRPr lang="en-US" sz="1350" dirty="0"/>
+              <a:t>Pelo menos nesse começo de sistema, até que todos estejam alinhados e o apontamento vire rotina natural do dia a dia.</a:t>
+            </a:r>
+            <a:endParaRPr lang="en-US" sz="1400" dirty="0"/>
           </a:p>
         </p:txBody>
       </p:sp>
@@ -4585,21 +4700,43 @@
         </p:nvSpPr>
         <p:spPr>
           <a:xfrm>
-            <a:off x="640080" y="3291840"/>
+            <a:off x="640080" y="4160520"/>
+            <a:ext cx="10927080" cy="2148840"/>
+          </a:xfrm>
+          <a:prstGeom prst="roundRect">
+            <a:avLst>
+              <a:gd name="adj" fmla="val 5106"/>
+            </a:avLst>
+          </a:prstGeom>
+          <a:solidFill>
+            <a:srgbClr val="FFF7ED"/>
+          </a:solidFill>
+          <a:ln/>
+        </p:spPr>
+      </p:sp>
+      <p:sp>
+        <p:nvSpPr>
+          <p:cNvPr id="9" name="Shape 6"/>
+          <p:cNvSpPr/>
+          <p:nvPr/>
+        </p:nvSpPr>
+        <p:spPr>
+          <a:xfrm>
+            <a:off x="960120" y="4480560"/>
             <a:ext cx="566928" cy="566928"/>
           </a:xfrm>
           <a:prstGeom prst="ellipse">
             <a:avLst/>
           </a:prstGeom>
           <a:solidFill>
-            <a:srgbClr val="1A3A5C"/>
+            <a:srgbClr val="D97706"/>
           </a:solidFill>
           <a:ln/>
         </p:spPr>
       </p:sp>
       <p:pic>
         <p:nvPicPr>
-          <p:cNvPr id="9" name="Image 1" descr="C:\Users\GUILHE~1.SAN\AppData\Local\Temp\claude\C--Users-guilherme-santos-Desktop-sistema-pcp\4d21c026-892e-446d-879f-b79089ffc749\scratchpad/icons/layers.png">    </p:cNvPr>
+          <p:cNvPr id="10" name="Image 1" descr="C:\Users\GUILHE~1.SAN\AppData\Local\Temp\claude\C--Users-guilherme-santos-Desktop-sistema-pcp\4d21c026-892e-446d-879f-b79089ffc749\scratchpad/icons/scissors.png">    </p:cNvPr>
           <p:cNvPicPr>
             <a:picLocks noChangeAspect="1"/>
           </p:cNvPicPr>
@@ -4613,7 +4750,7 @@
         </p:blipFill>
         <p:spPr>
           <a:xfrm>
-            <a:off x="702442" y="3354202"/>
+            <a:off x="1022482" y="4542922"/>
             <a:ext cx="442204" cy="442204"/>
           </a:xfrm>
           <a:prstGeom prst="rect">
@@ -4623,14 +4760,14 @@
       </p:pic>
       <p:sp>
         <p:nvSpPr>
-          <p:cNvPr id="10" name="Text 6"/>
-          <p:cNvSpPr/>
-          <p:nvPr/>
-        </p:nvSpPr>
-        <p:spPr>
-          <a:xfrm>
-            <a:off x="1463040" y="3127248"/>
-            <a:ext cx="9509760" cy="365760"/>
+          <p:cNvPr id="11" name="Text 7"/>
+          <p:cNvSpPr/>
+          <p:nvPr/>
+        </p:nvSpPr>
+        <p:spPr>
+          <a:xfrm>
+            <a:off x="1737360" y="4434840"/>
+            <a:ext cx="9555480" cy="411480"/>
           </a:xfrm>
           <a:prstGeom prst="rect">
             <a:avLst/>
@@ -4648,13 +4785,13 @@
             <a:r>
               <a:rPr lang="en-US" sz="1600" b="1" dirty="0">
                 <a:solidFill>
-                  <a:srgbClr val="1A3A5C"/>
+                  <a:srgbClr val="92400E"/>
                 </a:solidFill>
                 <a:latin typeface="Calibri" pitchFamily="34" charset="0"/>
                 <a:ea typeface="Calibri" pitchFamily="34" charset="-122"/>
                 <a:cs typeface="Calibri" pitchFamily="34" charset="-120"/>
               </a:rPr>
-              <a:t>Seguir o roteiro do pedido</a:t>
+              <a:t>Em avaliação: fim do fluxo informal do corte manual</a:t>
             </a:r>
             <a:endParaRPr lang="en-US" sz="1600" dirty="0"/>
           </a:p>
@@ -4662,299 +4799,49 @@
       </p:sp>
       <p:sp>
         <p:nvSpPr>
-          <p:cNvPr id="11" name="Text 7"/>
-          <p:cNvSpPr/>
-          <p:nvPr/>
-        </p:nvSpPr>
-        <p:spPr>
-          <a:xfrm>
-            <a:off x="1463040" y="3511296"/>
-            <a:ext cx="9509760" cy="594360"/>
-          </a:xfrm>
-          <a:prstGeom prst="rect">
-            <a:avLst/>
-          </a:prstGeom>
-          <a:noFill/>
-          <a:ln/>
-        </p:spPr>
-        <p:txBody>
-          <a:bodyPr wrap="square" rtlCol="0" anchor="ctr"/>
+          <p:cNvPr id="12" name="Text 8"/>
+          <p:cNvSpPr/>
+          <p:nvPr/>
+        </p:nvSpPr>
+        <p:spPr>
+          <a:xfrm>
+            <a:off x="1737360" y="4892040"/>
+            <a:ext cx="9509760" cy="1280160"/>
+          </a:xfrm>
+          <a:prstGeom prst="rect">
+            <a:avLst/>
+          </a:prstGeom>
+          <a:noFill/>
+          <a:ln/>
+        </p:spPr>
+        <p:txBody>
+          <a:bodyPr wrap="square" rtlCol="0" anchor="t"/>
           <a:lstStyle/>
           <a:p>
             <a:pPr indent="0" marL="0">
               <a:lnSpc>
-                <a:spcPct val="115000"/>
+                <a:spcPct val="125000"/>
               </a:lnSpc>
               <a:buNone/>
             </a:pPr>
             <a:r>
-              <a:rPr lang="en-US" sz="1350" dirty="0">
-                <a:solidFill>
-                  <a:srgbClr val="1F2937"/>
+              <a:rPr lang="en-US" sz="1400" dirty="0">
+                <a:solidFill>
+                  <a:srgbClr val="78350F"/>
                 </a:solidFill>
                 <a:latin typeface="Calibri" pitchFamily="34" charset="0"/>
                 <a:ea typeface="Calibri" pitchFamily="34" charset="-122"/>
                 <a:cs typeface="Calibri" pitchFamily="34" charset="-120"/>
               </a:rPr>
-              <a:t>Nenhuma etapa é pulada sem justificativa registrada. Se a quantidade precisa de retrabalho, ela passa pelo retrabalho.</a:t>
-            </a:r>
-            <a:endParaRPr lang="en-US" sz="1350" dirty="0"/>
-          </a:p>
-        </p:txBody>
-      </p:sp>
-      <p:sp>
-        <p:nvSpPr>
-          <p:cNvPr id="12" name="Shape 8"/>
-          <p:cNvSpPr/>
-          <p:nvPr/>
-        </p:nvSpPr>
-        <p:spPr>
-          <a:xfrm>
-            <a:off x="640080" y="4453128"/>
-            <a:ext cx="566928" cy="566928"/>
-          </a:xfrm>
-          <a:prstGeom prst="ellipse">
-            <a:avLst/>
-          </a:prstGeom>
-          <a:solidFill>
-            <a:srgbClr val="1A3A5C"/>
-          </a:solidFill>
-          <a:ln/>
-        </p:spPr>
-      </p:sp>
-      <p:pic>
-        <p:nvPicPr>
-          <p:cNvPr id="13" name="Image 2" descr="C:\Users\GUILHE~1.SAN\AppData\Local\Temp\claude\C--Users-guilherme-santos-Desktop-sistema-pcp\4d21c026-892e-446d-879f-b79089ffc749\scratchpad/icons/package.png">    </p:cNvPr>
-          <p:cNvPicPr>
-            <a:picLocks noChangeAspect="1"/>
-          </p:cNvPicPr>
-          <p:nvPr/>
-        </p:nvPicPr>
-        <p:blipFill>
-          <a:blip r:embed="rId3"/>
-          <a:stretch>
-            <a:fillRect/>
-          </a:stretch>
-        </p:blipFill>
-        <p:spPr>
-          <a:xfrm>
-            <a:off x="702442" y="4515490"/>
-            <a:ext cx="442204" cy="442204"/>
-          </a:xfrm>
-          <a:prstGeom prst="rect">
-            <a:avLst/>
-          </a:prstGeom>
-        </p:spPr>
-      </p:pic>
-      <p:sp>
-        <p:nvSpPr>
-          <p:cNvPr id="14" name="Text 9"/>
-          <p:cNvSpPr/>
-          <p:nvPr/>
-        </p:nvSpPr>
-        <p:spPr>
-          <a:xfrm>
-            <a:off x="1463040" y="4288536"/>
-            <a:ext cx="9509760" cy="365760"/>
-          </a:xfrm>
-          <a:prstGeom prst="rect">
-            <a:avLst/>
-          </a:prstGeom>
-          <a:noFill/>
-          <a:ln/>
-        </p:spPr>
-        <p:txBody>
-          <a:bodyPr wrap="square" rtlCol="0" anchor="ctr"/>
-          <a:lstStyle/>
-          <a:p>
-            <a:pPr indent="0" marL="0">
-              <a:buNone/>
-            </a:pPr>
-            <a:r>
-              <a:rPr lang="en-US" sz="1600" b="1" dirty="0">
-                <a:solidFill>
-                  <a:srgbClr val="1A3A5C"/>
-                </a:solidFill>
-                <a:latin typeface="Calibri" pitchFamily="34" charset="0"/>
-                <a:ea typeface="Calibri" pitchFamily="34" charset="-122"/>
-                <a:cs typeface="Calibri" pitchFamily="34" charset="-120"/>
-              </a:rPr>
-              <a:t>Separar o que for apontado separado</a:t>
-            </a:r>
-            <a:endParaRPr lang="en-US" sz="1600" dirty="0"/>
-          </a:p>
-        </p:txBody>
-      </p:sp>
-      <p:sp>
-        <p:nvSpPr>
-          <p:cNvPr id="15" name="Text 10"/>
-          <p:cNvSpPr/>
-          <p:nvPr/>
-        </p:nvSpPr>
-        <p:spPr>
-          <a:xfrm>
-            <a:off x="1463040" y="4672584"/>
-            <a:ext cx="9509760" cy="594360"/>
-          </a:xfrm>
-          <a:prstGeom prst="rect">
-            <a:avLst/>
-          </a:prstGeom>
-          <a:noFill/>
-          <a:ln/>
-        </p:spPr>
-        <p:txBody>
-          <a:bodyPr wrap="square" rtlCol="0" anchor="ctr"/>
-          <a:lstStyle/>
-          <a:p>
-            <a:pPr indent="0" marL="0">
-              <a:lnSpc>
-                <a:spcPct val="115000"/>
-              </a:lnSpc>
-              <a:buNone/>
-            </a:pPr>
-            <a:r>
-              <a:rPr lang="en-US" sz="1350" dirty="0">
-                <a:solidFill>
-                  <a:srgbClr val="1F2937"/>
-                </a:solidFill>
-                <a:latin typeface="Calibri" pitchFamily="34" charset="0"/>
-                <a:ea typeface="Calibri" pitchFamily="34" charset="-122"/>
-                <a:cs typeface="Calibri" pitchFamily="34" charset="-120"/>
-              </a:rPr>
-              <a:t>Quantidades de apontamentos/setores diferentes não são embaladas ou misturadas juntas.</a:t>
-            </a:r>
-            <a:endParaRPr lang="en-US" sz="1350" dirty="0"/>
-          </a:p>
-        </p:txBody>
-      </p:sp>
-      <p:sp>
-        <p:nvSpPr>
-          <p:cNvPr id="16" name="Shape 11"/>
-          <p:cNvSpPr/>
-          <p:nvPr/>
-        </p:nvSpPr>
-        <p:spPr>
-          <a:xfrm>
-            <a:off x="640080" y="5614416"/>
-            <a:ext cx="566928" cy="566928"/>
-          </a:xfrm>
-          <a:prstGeom prst="ellipse">
-            <a:avLst/>
-          </a:prstGeom>
-          <a:solidFill>
-            <a:srgbClr val="1A3A5C"/>
-          </a:solidFill>
-          <a:ln/>
-        </p:spPr>
-      </p:sp>
-      <p:pic>
-        <p:nvPicPr>
-          <p:cNvPr id="17" name="Image 3" descr="C:\Users\GUILHE~1.SAN\AppData\Local\Temp\claude\C--Users-guilherme-santos-Desktop-sistema-pcp\4d21c026-892e-446d-879f-b79089ffc749\scratchpad/icons/alert.png">    </p:cNvPr>
-          <p:cNvPicPr>
-            <a:picLocks noChangeAspect="1"/>
-          </p:cNvPicPr>
-          <p:nvPr/>
-        </p:nvPicPr>
-        <p:blipFill>
-          <a:blip r:embed="rId4"/>
-          <a:stretch>
-            <a:fillRect/>
-          </a:stretch>
-        </p:blipFill>
-        <p:spPr>
-          <a:xfrm>
-            <a:off x="702442" y="5676778"/>
-            <a:ext cx="442204" cy="442204"/>
-          </a:xfrm>
-          <a:prstGeom prst="rect">
-            <a:avLst/>
-          </a:prstGeom>
-        </p:spPr>
-      </p:pic>
-      <p:sp>
-        <p:nvSpPr>
-          <p:cNvPr id="18" name="Text 12"/>
-          <p:cNvSpPr/>
-          <p:nvPr/>
-        </p:nvSpPr>
-        <p:spPr>
-          <a:xfrm>
-            <a:off x="1463040" y="5449824"/>
-            <a:ext cx="9509760" cy="365760"/>
-          </a:xfrm>
-          <a:prstGeom prst="rect">
-            <a:avLst/>
-          </a:prstGeom>
-          <a:noFill/>
-          <a:ln/>
-        </p:spPr>
-        <p:txBody>
-          <a:bodyPr wrap="square" rtlCol="0" anchor="ctr"/>
-          <a:lstStyle/>
-          <a:p>
-            <a:pPr indent="0" marL="0">
-              <a:buNone/>
-            </a:pPr>
-            <a:r>
-              <a:rPr lang="en-US" sz="1600" b="1" dirty="0">
-                <a:solidFill>
-                  <a:srgbClr val="1A3A5C"/>
-                </a:solidFill>
-                <a:latin typeface="Calibri" pitchFamily="34" charset="0"/>
-                <a:ea typeface="Calibri" pitchFamily="34" charset="-122"/>
-                <a:cs typeface="Calibri" pitchFamily="34" charset="-120"/>
-              </a:rPr>
-              <a:t>Reportar erro antes de seguir</a:t>
-            </a:r>
-            <a:endParaRPr lang="en-US" sz="1600" dirty="0"/>
-          </a:p>
-        </p:txBody>
-      </p:sp>
-      <p:sp>
-        <p:nvSpPr>
-          <p:cNvPr id="19" name="Text 13"/>
-          <p:cNvSpPr/>
-          <p:nvPr/>
-        </p:nvSpPr>
-        <p:spPr>
-          <a:xfrm>
-            <a:off x="1463040" y="5833872"/>
-            <a:ext cx="9509760" cy="594360"/>
-          </a:xfrm>
-          <a:prstGeom prst="rect">
-            <a:avLst/>
-          </a:prstGeom>
-          <a:noFill/>
-          <a:ln/>
-        </p:spPr>
-        <p:txBody>
-          <a:bodyPr wrap="square" rtlCol="0" anchor="ctr"/>
-          <a:lstStyle/>
-          <a:p>
-            <a:pPr indent="0" marL="0">
-              <a:lnSpc>
-                <a:spcPct val="115000"/>
-              </a:lnSpc>
-              <a:buNone/>
-            </a:pPr>
-            <a:r>
-              <a:rPr lang="en-US" sz="1350" dirty="0">
-                <a:solidFill>
-                  <a:srgbClr val="1F2937"/>
-                </a:solidFill>
-                <a:latin typeface="Calibri" pitchFamily="34" charset="0"/>
-                <a:ea typeface="Calibri" pitchFamily="34" charset="-122"/>
-                <a:cs typeface="Calibri" pitchFamily="34" charset="-120"/>
-              </a:rPr>
-              <a:t>Etapa pulada, quantidade misturada, apontamento esquecido: avisar o PCP antes de continuar. Corrigir depois é bem mais difícil.</a:t>
-            </a:r>
-            <a:endParaRPr lang="en-US" sz="1350" dirty="0"/>
-          </a:p>
-        </p:txBody>
-      </p:sp>
-      <p:sp>
-        <p:nvSpPr>
-          <p:cNvPr id="20" name="Text 14"/>
+              <a:t>Está sendo avaliada a possibilidade de retirar os pedidos de corte manual do fluxo informal — hoje acompanhados "no olho", sem passar pelo apontamento no sistema. A ideia é que nenhum pedido siga sem estar refletido no sistema, corte manual incluído.</a:t>
+            </a:r>
+            <a:endParaRPr lang="en-US" sz="1400" dirty="0"/>
+          </a:p>
+        </p:txBody>
+      </p:sp>
+      <p:sp>
+        <p:nvSpPr>
+          <p:cNvPr id="13" name="Text 9"/>
           <p:cNvSpPr/>
           <p:nvPr/>
         </p:nvSpPr>
@@ -5002,6 +4889,655 @@
 <file path=ppt/slides/slide8.xml><?xml version="1.0" encoding="utf-8"?>
 <p:sld xmlns:a="http://schemas.openxmlformats.org/drawingml/2006/main" xmlns:r="http://schemas.openxmlformats.org/officeDocument/2006/relationships" xmlns:p="http://schemas.openxmlformats.org/presentationml/2006/main">
   <p:cSld name="Slide 8">
+    <p:bg>
+      <p:bgPr>
+        <a:solidFill>
+          <a:srgbClr val="FFFFFF"/>
+        </a:solidFill>
+      </p:bgPr>
+    </p:bg>
+    <p:spTree>
+      <p:nvGrpSpPr>
+        <p:cNvPr id="1" name=""/>
+        <p:cNvGrpSpPr/>
+        <p:nvPr/>
+      </p:nvGrpSpPr>
+      <p:grpSpPr>
+        <a:xfrm>
+          <a:off x="0" y="0"/>
+          <a:ext cx="0" cy="0"/>
+          <a:chOff x="0" y="0"/>
+          <a:chExt cx="0" cy="0"/>
+        </a:xfrm>
+      </p:grpSpPr>
+      <p:sp>
+        <p:nvSpPr>
+          <p:cNvPr id="2" name="Text 0"/>
+          <p:cNvSpPr/>
+          <p:nvPr/>
+        </p:nvSpPr>
+        <p:spPr>
+          <a:xfrm>
+            <a:off x="640080" y="502920"/>
+            <a:ext cx="8229600" cy="320040"/>
+          </a:xfrm>
+          <a:prstGeom prst="rect">
+            <a:avLst/>
+          </a:prstGeom>
+          <a:noFill/>
+          <a:ln/>
+        </p:spPr>
+        <p:txBody>
+          <a:bodyPr wrap="square" rtlCol="0" anchor="ctr"/>
+          <a:lstStyle/>
+          <a:p>
+            <a:pPr indent="0" marL="0">
+              <a:buNone/>
+            </a:pPr>
+            <a:r>
+              <a:rPr lang="en-US" sz="1200" b="1" spc="200" kern="0" dirty="0">
+                <a:solidFill>
+                  <a:srgbClr val="D97706"/>
+                </a:solidFill>
+                <a:latin typeface="Calibri" pitchFamily="34" charset="0"/>
+                <a:ea typeface="Calibri" pitchFamily="34" charset="-122"/>
+                <a:cs typeface="Calibri" pitchFamily="34" charset="-120"/>
+              </a:rPr>
+              <a:t>A PARTIR DE AGORA</a:t>
+            </a:r>
+            <a:endParaRPr lang="en-US" sz="1200" dirty="0"/>
+          </a:p>
+        </p:txBody>
+      </p:sp>
+      <p:sp>
+        <p:nvSpPr>
+          <p:cNvPr id="3" name="Text 1"/>
+          <p:cNvSpPr/>
+          <p:nvPr/>
+        </p:nvSpPr>
+        <p:spPr>
+          <a:xfrm>
+            <a:off x="640080" y="868680"/>
+            <a:ext cx="10881360" cy="822960"/>
+          </a:xfrm>
+          <a:prstGeom prst="rect">
+            <a:avLst/>
+          </a:prstGeom>
+          <a:noFill/>
+          <a:ln/>
+        </p:spPr>
+        <p:txBody>
+          <a:bodyPr wrap="square" rtlCol="0" anchor="ctr"/>
+          <a:lstStyle/>
+          <a:p>
+            <a:pPr indent="0" marL="0">
+              <a:buNone/>
+            </a:pPr>
+            <a:r>
+              <a:rPr lang="en-US" sz="2800" b="1" dirty="0">
+                <a:solidFill>
+                  <a:srgbClr val="1A3A5C"/>
+                </a:solidFill>
+                <a:latin typeface="Cambria" pitchFamily="34" charset="0"/>
+                <a:ea typeface="Cambria" pitchFamily="34" charset="-122"/>
+                <a:cs typeface="Cambria" pitchFamily="34" charset="-120"/>
+              </a:rPr>
+              <a:t>O que cada líder precisa garantir na sua equipe</a:t>
+            </a:r>
+            <a:endParaRPr lang="en-US" sz="2800" dirty="0"/>
+          </a:p>
+        </p:txBody>
+      </p:sp>
+      <p:sp>
+        <p:nvSpPr>
+          <p:cNvPr id="4" name="Shape 2"/>
+          <p:cNvSpPr/>
+          <p:nvPr/>
+        </p:nvSpPr>
+        <p:spPr>
+          <a:xfrm>
+            <a:off x="640080" y="2130552"/>
+            <a:ext cx="566928" cy="566928"/>
+          </a:xfrm>
+          <a:prstGeom prst="ellipse">
+            <a:avLst/>
+          </a:prstGeom>
+          <a:solidFill>
+            <a:srgbClr val="1A3A5C"/>
+          </a:solidFill>
+          <a:ln/>
+        </p:spPr>
+      </p:sp>
+      <p:pic>
+        <p:nvPicPr>
+          <p:cNvPr id="5" name="Image 0" descr="C:\Users\GUILHE~1.SAN\AppData\Local\Temp\claude\C--Users-guilherme-santos-Desktop-sistema-pcp\4d21c026-892e-446d-879f-b79089ffc749\scratchpad/icons/clipboard.png">    </p:cNvPr>
+          <p:cNvPicPr>
+            <a:picLocks noChangeAspect="1"/>
+          </p:cNvPicPr>
+          <p:nvPr/>
+        </p:nvPicPr>
+        <p:blipFill>
+          <a:blip r:embed="rId1"/>
+          <a:stretch>
+            <a:fillRect/>
+          </a:stretch>
+        </p:blipFill>
+        <p:spPr>
+          <a:xfrm>
+            <a:off x="702442" y="2192914"/>
+            <a:ext cx="442204" cy="442204"/>
+          </a:xfrm>
+          <a:prstGeom prst="rect">
+            <a:avLst/>
+          </a:prstGeom>
+        </p:spPr>
+      </p:pic>
+      <p:sp>
+        <p:nvSpPr>
+          <p:cNvPr id="6" name="Text 3"/>
+          <p:cNvSpPr/>
+          <p:nvPr/>
+        </p:nvSpPr>
+        <p:spPr>
+          <a:xfrm>
+            <a:off x="1463040" y="1965960"/>
+            <a:ext cx="9509760" cy="365760"/>
+          </a:xfrm>
+          <a:prstGeom prst="rect">
+            <a:avLst/>
+          </a:prstGeom>
+          <a:noFill/>
+          <a:ln/>
+        </p:spPr>
+        <p:txBody>
+          <a:bodyPr wrap="square" rtlCol="0" anchor="ctr"/>
+          <a:lstStyle/>
+          <a:p>
+            <a:pPr indent="0" marL="0">
+              <a:buNone/>
+            </a:pPr>
+            <a:r>
+              <a:rPr lang="en-US" sz="1600" b="1" dirty="0">
+                <a:solidFill>
+                  <a:srgbClr val="1A3A5C"/>
+                </a:solidFill>
+                <a:latin typeface="Calibri" pitchFamily="34" charset="0"/>
+                <a:ea typeface="Calibri" pitchFamily="34" charset="-122"/>
+                <a:cs typeface="Calibri" pitchFamily="34" charset="-120"/>
+              </a:rPr>
+              <a:t>Apontar sempre, na hora</a:t>
+            </a:r>
+            <a:endParaRPr lang="en-US" sz="1600" dirty="0"/>
+          </a:p>
+        </p:txBody>
+      </p:sp>
+      <p:sp>
+        <p:nvSpPr>
+          <p:cNvPr id="7" name="Text 4"/>
+          <p:cNvSpPr/>
+          <p:nvPr/>
+        </p:nvSpPr>
+        <p:spPr>
+          <a:xfrm>
+            <a:off x="1463040" y="2350008"/>
+            <a:ext cx="9509760" cy="594360"/>
+          </a:xfrm>
+          <a:prstGeom prst="rect">
+            <a:avLst/>
+          </a:prstGeom>
+          <a:noFill/>
+          <a:ln/>
+        </p:spPr>
+        <p:txBody>
+          <a:bodyPr wrap="square" rtlCol="0" anchor="ctr"/>
+          <a:lstStyle/>
+          <a:p>
+            <a:pPr indent="0" marL="0">
+              <a:lnSpc>
+                <a:spcPct val="115000"/>
+              </a:lnSpc>
+              <a:buNone/>
+            </a:pPr>
+            <a:r>
+              <a:rPr lang="en-US" sz="1350" dirty="0">
+                <a:solidFill>
+                  <a:srgbClr val="1F2937"/>
+                </a:solidFill>
+                <a:latin typeface="Calibri" pitchFamily="34" charset="0"/>
+                <a:ea typeface="Calibri" pitchFamily="34" charset="-122"/>
+                <a:cs typeface="Calibri" pitchFamily="34" charset="-120"/>
+              </a:rPr>
+              <a:t>Cada movimento é registrado no sistema no momento em que acontece — não depois, não "quando der tempo".</a:t>
+            </a:r>
+            <a:endParaRPr lang="en-US" sz="1350" dirty="0"/>
+          </a:p>
+        </p:txBody>
+      </p:sp>
+      <p:sp>
+        <p:nvSpPr>
+          <p:cNvPr id="8" name="Shape 5"/>
+          <p:cNvSpPr/>
+          <p:nvPr/>
+        </p:nvSpPr>
+        <p:spPr>
+          <a:xfrm>
+            <a:off x="640080" y="3291840"/>
+            <a:ext cx="566928" cy="566928"/>
+          </a:xfrm>
+          <a:prstGeom prst="ellipse">
+            <a:avLst/>
+          </a:prstGeom>
+          <a:solidFill>
+            <a:srgbClr val="1A3A5C"/>
+          </a:solidFill>
+          <a:ln/>
+        </p:spPr>
+      </p:sp>
+      <p:pic>
+        <p:nvPicPr>
+          <p:cNvPr id="9" name="Image 1" descr="C:\Users\GUILHE~1.SAN\AppData\Local\Temp\claude\C--Users-guilherme-santos-Desktop-sistema-pcp\4d21c026-892e-446d-879f-b79089ffc749\scratchpad/icons/layers.png">    </p:cNvPr>
+          <p:cNvPicPr>
+            <a:picLocks noChangeAspect="1"/>
+          </p:cNvPicPr>
+          <p:nvPr/>
+        </p:nvPicPr>
+        <p:blipFill>
+          <a:blip r:embed="rId2"/>
+          <a:stretch>
+            <a:fillRect/>
+          </a:stretch>
+        </p:blipFill>
+        <p:spPr>
+          <a:xfrm>
+            <a:off x="702442" y="3354202"/>
+            <a:ext cx="442204" cy="442204"/>
+          </a:xfrm>
+          <a:prstGeom prst="rect">
+            <a:avLst/>
+          </a:prstGeom>
+        </p:spPr>
+      </p:pic>
+      <p:sp>
+        <p:nvSpPr>
+          <p:cNvPr id="10" name="Text 6"/>
+          <p:cNvSpPr/>
+          <p:nvPr/>
+        </p:nvSpPr>
+        <p:spPr>
+          <a:xfrm>
+            <a:off x="1463040" y="3127248"/>
+            <a:ext cx="9509760" cy="365760"/>
+          </a:xfrm>
+          <a:prstGeom prst="rect">
+            <a:avLst/>
+          </a:prstGeom>
+          <a:noFill/>
+          <a:ln/>
+        </p:spPr>
+        <p:txBody>
+          <a:bodyPr wrap="square" rtlCol="0" anchor="ctr"/>
+          <a:lstStyle/>
+          <a:p>
+            <a:pPr indent="0" marL="0">
+              <a:buNone/>
+            </a:pPr>
+            <a:r>
+              <a:rPr lang="en-US" sz="1600" b="1" dirty="0">
+                <a:solidFill>
+                  <a:srgbClr val="1A3A5C"/>
+                </a:solidFill>
+                <a:latin typeface="Calibri" pitchFamily="34" charset="0"/>
+                <a:ea typeface="Calibri" pitchFamily="34" charset="-122"/>
+                <a:cs typeface="Calibri" pitchFamily="34" charset="-120"/>
+              </a:rPr>
+              <a:t>Seguir o roteiro do pedido</a:t>
+            </a:r>
+            <a:endParaRPr lang="en-US" sz="1600" dirty="0"/>
+          </a:p>
+        </p:txBody>
+      </p:sp>
+      <p:sp>
+        <p:nvSpPr>
+          <p:cNvPr id="11" name="Text 7"/>
+          <p:cNvSpPr/>
+          <p:nvPr/>
+        </p:nvSpPr>
+        <p:spPr>
+          <a:xfrm>
+            <a:off x="1463040" y="3511296"/>
+            <a:ext cx="9509760" cy="594360"/>
+          </a:xfrm>
+          <a:prstGeom prst="rect">
+            <a:avLst/>
+          </a:prstGeom>
+          <a:noFill/>
+          <a:ln/>
+        </p:spPr>
+        <p:txBody>
+          <a:bodyPr wrap="square" rtlCol="0" anchor="ctr"/>
+          <a:lstStyle/>
+          <a:p>
+            <a:pPr indent="0" marL="0">
+              <a:lnSpc>
+                <a:spcPct val="115000"/>
+              </a:lnSpc>
+              <a:buNone/>
+            </a:pPr>
+            <a:r>
+              <a:rPr lang="en-US" sz="1350" dirty="0">
+                <a:solidFill>
+                  <a:srgbClr val="1F2937"/>
+                </a:solidFill>
+                <a:latin typeface="Calibri" pitchFamily="34" charset="0"/>
+                <a:ea typeface="Calibri" pitchFamily="34" charset="-122"/>
+                <a:cs typeface="Calibri" pitchFamily="34" charset="-120"/>
+              </a:rPr>
+              <a:t>Nenhuma etapa é pulada sem justificativa registrada. Se a quantidade precisa de retrabalho, ela passa pelo retrabalho.</a:t>
+            </a:r>
+            <a:endParaRPr lang="en-US" sz="1350" dirty="0"/>
+          </a:p>
+        </p:txBody>
+      </p:sp>
+      <p:sp>
+        <p:nvSpPr>
+          <p:cNvPr id="12" name="Shape 8"/>
+          <p:cNvSpPr/>
+          <p:nvPr/>
+        </p:nvSpPr>
+        <p:spPr>
+          <a:xfrm>
+            <a:off x="640080" y="4453128"/>
+            <a:ext cx="566928" cy="566928"/>
+          </a:xfrm>
+          <a:prstGeom prst="ellipse">
+            <a:avLst/>
+          </a:prstGeom>
+          <a:solidFill>
+            <a:srgbClr val="1A3A5C"/>
+          </a:solidFill>
+          <a:ln/>
+        </p:spPr>
+      </p:sp>
+      <p:pic>
+        <p:nvPicPr>
+          <p:cNvPr id="13" name="Image 2" descr="C:\Users\GUILHE~1.SAN\AppData\Local\Temp\claude\C--Users-guilherme-santos-Desktop-sistema-pcp\4d21c026-892e-446d-879f-b79089ffc749\scratchpad/icons/package.png">    </p:cNvPr>
+          <p:cNvPicPr>
+            <a:picLocks noChangeAspect="1"/>
+          </p:cNvPicPr>
+          <p:nvPr/>
+        </p:nvPicPr>
+        <p:blipFill>
+          <a:blip r:embed="rId3"/>
+          <a:stretch>
+            <a:fillRect/>
+          </a:stretch>
+        </p:blipFill>
+        <p:spPr>
+          <a:xfrm>
+            <a:off x="702442" y="4515490"/>
+            <a:ext cx="442204" cy="442204"/>
+          </a:xfrm>
+          <a:prstGeom prst="rect">
+            <a:avLst/>
+          </a:prstGeom>
+        </p:spPr>
+      </p:pic>
+      <p:sp>
+        <p:nvSpPr>
+          <p:cNvPr id="14" name="Text 9"/>
+          <p:cNvSpPr/>
+          <p:nvPr/>
+        </p:nvSpPr>
+        <p:spPr>
+          <a:xfrm>
+            <a:off x="1463040" y="4288536"/>
+            <a:ext cx="9509760" cy="365760"/>
+          </a:xfrm>
+          <a:prstGeom prst="rect">
+            <a:avLst/>
+          </a:prstGeom>
+          <a:noFill/>
+          <a:ln/>
+        </p:spPr>
+        <p:txBody>
+          <a:bodyPr wrap="square" rtlCol="0" anchor="ctr"/>
+          <a:lstStyle/>
+          <a:p>
+            <a:pPr indent="0" marL="0">
+              <a:buNone/>
+            </a:pPr>
+            <a:r>
+              <a:rPr lang="en-US" sz="1600" b="1" dirty="0">
+                <a:solidFill>
+                  <a:srgbClr val="1A3A5C"/>
+                </a:solidFill>
+                <a:latin typeface="Calibri" pitchFamily="34" charset="0"/>
+                <a:ea typeface="Calibri" pitchFamily="34" charset="-122"/>
+                <a:cs typeface="Calibri" pitchFamily="34" charset="-120"/>
+              </a:rPr>
+              <a:t>Separar o que for apontado separado</a:t>
+            </a:r>
+            <a:endParaRPr lang="en-US" sz="1600" dirty="0"/>
+          </a:p>
+        </p:txBody>
+      </p:sp>
+      <p:sp>
+        <p:nvSpPr>
+          <p:cNvPr id="15" name="Text 10"/>
+          <p:cNvSpPr/>
+          <p:nvPr/>
+        </p:nvSpPr>
+        <p:spPr>
+          <a:xfrm>
+            <a:off x="1463040" y="4672584"/>
+            <a:ext cx="9509760" cy="594360"/>
+          </a:xfrm>
+          <a:prstGeom prst="rect">
+            <a:avLst/>
+          </a:prstGeom>
+          <a:noFill/>
+          <a:ln/>
+        </p:spPr>
+        <p:txBody>
+          <a:bodyPr wrap="square" rtlCol="0" anchor="ctr"/>
+          <a:lstStyle/>
+          <a:p>
+            <a:pPr indent="0" marL="0">
+              <a:lnSpc>
+                <a:spcPct val="115000"/>
+              </a:lnSpc>
+              <a:buNone/>
+            </a:pPr>
+            <a:r>
+              <a:rPr lang="en-US" sz="1350" dirty="0">
+                <a:solidFill>
+                  <a:srgbClr val="1F2937"/>
+                </a:solidFill>
+                <a:latin typeface="Calibri" pitchFamily="34" charset="0"/>
+                <a:ea typeface="Calibri" pitchFamily="34" charset="-122"/>
+                <a:cs typeface="Calibri" pitchFamily="34" charset="-120"/>
+              </a:rPr>
+              <a:t>Quantidades de apontamentos/setores diferentes não são embaladas ou misturadas juntas.</a:t>
+            </a:r>
+            <a:endParaRPr lang="en-US" sz="1350" dirty="0"/>
+          </a:p>
+        </p:txBody>
+      </p:sp>
+      <p:sp>
+        <p:nvSpPr>
+          <p:cNvPr id="16" name="Shape 11"/>
+          <p:cNvSpPr/>
+          <p:nvPr/>
+        </p:nvSpPr>
+        <p:spPr>
+          <a:xfrm>
+            <a:off x="640080" y="5614416"/>
+            <a:ext cx="566928" cy="566928"/>
+          </a:xfrm>
+          <a:prstGeom prst="ellipse">
+            <a:avLst/>
+          </a:prstGeom>
+          <a:solidFill>
+            <a:srgbClr val="1A3A5C"/>
+          </a:solidFill>
+          <a:ln/>
+        </p:spPr>
+      </p:sp>
+      <p:pic>
+        <p:nvPicPr>
+          <p:cNvPr id="17" name="Image 3" descr="C:\Users\GUILHE~1.SAN\AppData\Local\Temp\claude\C--Users-guilherme-santos-Desktop-sistema-pcp\4d21c026-892e-446d-879f-b79089ffc749\scratchpad/icons/alert.png">    </p:cNvPr>
+          <p:cNvPicPr>
+            <a:picLocks noChangeAspect="1"/>
+          </p:cNvPicPr>
+          <p:nvPr/>
+        </p:nvPicPr>
+        <p:blipFill>
+          <a:blip r:embed="rId4"/>
+          <a:stretch>
+            <a:fillRect/>
+          </a:stretch>
+        </p:blipFill>
+        <p:spPr>
+          <a:xfrm>
+            <a:off x="702442" y="5676778"/>
+            <a:ext cx="442204" cy="442204"/>
+          </a:xfrm>
+          <a:prstGeom prst="rect">
+            <a:avLst/>
+          </a:prstGeom>
+        </p:spPr>
+      </p:pic>
+      <p:sp>
+        <p:nvSpPr>
+          <p:cNvPr id="18" name="Text 12"/>
+          <p:cNvSpPr/>
+          <p:nvPr/>
+        </p:nvSpPr>
+        <p:spPr>
+          <a:xfrm>
+            <a:off x="1463040" y="5449824"/>
+            <a:ext cx="9509760" cy="365760"/>
+          </a:xfrm>
+          <a:prstGeom prst="rect">
+            <a:avLst/>
+          </a:prstGeom>
+          <a:noFill/>
+          <a:ln/>
+        </p:spPr>
+        <p:txBody>
+          <a:bodyPr wrap="square" rtlCol="0" anchor="ctr"/>
+          <a:lstStyle/>
+          <a:p>
+            <a:pPr indent="0" marL="0">
+              <a:buNone/>
+            </a:pPr>
+            <a:r>
+              <a:rPr lang="en-US" sz="1600" b="1" dirty="0">
+                <a:solidFill>
+                  <a:srgbClr val="1A3A5C"/>
+                </a:solidFill>
+                <a:latin typeface="Calibri" pitchFamily="34" charset="0"/>
+                <a:ea typeface="Calibri" pitchFamily="34" charset="-122"/>
+                <a:cs typeface="Calibri" pitchFamily="34" charset="-120"/>
+              </a:rPr>
+              <a:t>Reportar erro antes de seguir</a:t>
+            </a:r>
+            <a:endParaRPr lang="en-US" sz="1600" dirty="0"/>
+          </a:p>
+        </p:txBody>
+      </p:sp>
+      <p:sp>
+        <p:nvSpPr>
+          <p:cNvPr id="19" name="Text 13"/>
+          <p:cNvSpPr/>
+          <p:nvPr/>
+        </p:nvSpPr>
+        <p:spPr>
+          <a:xfrm>
+            <a:off x="1463040" y="5833872"/>
+            <a:ext cx="9509760" cy="594360"/>
+          </a:xfrm>
+          <a:prstGeom prst="rect">
+            <a:avLst/>
+          </a:prstGeom>
+          <a:noFill/>
+          <a:ln/>
+        </p:spPr>
+        <p:txBody>
+          <a:bodyPr wrap="square" rtlCol="0" anchor="ctr"/>
+          <a:lstStyle/>
+          <a:p>
+            <a:pPr indent="0" marL="0">
+              <a:lnSpc>
+                <a:spcPct val="115000"/>
+              </a:lnSpc>
+              <a:buNone/>
+            </a:pPr>
+            <a:r>
+              <a:rPr lang="en-US" sz="1350" dirty="0">
+                <a:solidFill>
+                  <a:srgbClr val="1F2937"/>
+                </a:solidFill>
+                <a:latin typeface="Calibri" pitchFamily="34" charset="0"/>
+                <a:ea typeface="Calibri" pitchFamily="34" charset="-122"/>
+                <a:cs typeface="Calibri" pitchFamily="34" charset="-120"/>
+              </a:rPr>
+              <a:t>Etapa pulada, quantidade misturada, apontamento esquecido: avisar o PCP antes de continuar. Corrigir depois é bem mais difícil.</a:t>
+            </a:r>
+            <a:endParaRPr lang="en-US" sz="1350" dirty="0"/>
+          </a:p>
+        </p:txBody>
+      </p:sp>
+      <p:sp>
+        <p:nvSpPr>
+          <p:cNvPr id="20" name="Text 14"/>
+          <p:cNvSpPr/>
+          <p:nvPr/>
+        </p:nvSpPr>
+        <p:spPr>
+          <a:xfrm>
+            <a:off x="11368735" y="6355080"/>
+            <a:ext cx="548640" cy="320040"/>
+          </a:xfrm>
+          <a:prstGeom prst="rect">
+            <a:avLst/>
+          </a:prstGeom>
+          <a:noFill/>
+          <a:ln/>
+        </p:spPr>
+        <p:txBody>
+          <a:bodyPr wrap="square" rtlCol="0" anchor="ctr"/>
+          <a:lstStyle/>
+          <a:p>
+            <a:pPr algn="r" indent="0" marL="0">
+              <a:buNone/>
+            </a:pPr>
+            <a:r>
+              <a:rPr lang="en-US" sz="1000" dirty="0">
+                <a:solidFill>
+                  <a:srgbClr val="5A6A80"/>
+                </a:solidFill>
+                <a:latin typeface="Calibri" pitchFamily="34" charset="0"/>
+                <a:ea typeface="Calibri" pitchFamily="34" charset="-122"/>
+                <a:cs typeface="Calibri" pitchFamily="34" charset="-120"/>
+              </a:rPr>
+              <a:t>08</a:t>
+            </a:r>
+            <a:endParaRPr lang="en-US" sz="1000" dirty="0"/>
+          </a:p>
+        </p:txBody>
+      </p:sp>
+    </p:spTree>
+  </p:cSld>
+  <p:clrMapOvr>
+    <a:masterClrMapping/>
+  </p:clrMapOvr>
+</p:sld>
+</file>
+
+<file path=ppt/slides/slide9.xml><?xml version="1.0" encoding="utf-8"?>
+<p:sld xmlns:a="http://schemas.openxmlformats.org/drawingml/2006/main" xmlns:r="http://schemas.openxmlformats.org/officeDocument/2006/relationships" xmlns:p="http://schemas.openxmlformats.org/presentationml/2006/main">
+  <p:cSld name="Slide 9">
     <p:bg>
       <p:bgPr>
         <a:solidFill>

</xml_diff>